<commit_message>
Sync the technical explainer deck with the final paper and the Rheon rename
Slide 3 now names the Rheon pre-gate and the anchored sliding-window ridge; the benchmark table carries the final batch/online numbers for Mackey-Glass 6-step, 12-step, and Lorenz (8.8x-25.2x over the ESN); the comparison table says Rheon gate.
</commit_message>
<xml_diff>
--- a/The-Ghost-Lattice/Ghost-Lattice_QNN_Explainer.pptx
+++ b/The-Ghost-Lattice/Ghost-Lattice_QNN_Explainer.pptx
@@ -3707,7 +3707,7 @@
                             <a:srgbClr val="212121"/>
                           </a:solidFill>
                         </a:rPr>
-                        <a:t>Evolved LNN gate (Chaos Algorithm)</a:t>
+                        <a:t>Evolved Rheon gate (Chaos Algorithm)</a:t>
                       </a:r>
                     </a:p>
                   </a:txBody>
@@ -4391,7 +4391,7 @@
                 </a:solidFill>
                 <a:latin typeface="Calibri"/>
               </a:rPr>
-              <a:t>1  LNN pre-gate</a:t>
+              <a:t>1  Rheon pre-gate</a:t>
             </a:r>
           </a:p>
           <a:p>
@@ -4503,7 +4503,7 @@
                 </a:solidFill>
                 <a:latin typeface="Calibri"/>
               </a:rPr>
-              <a:t>• Ridge regression offline; sliding-window ridge or warm-started RLS online — always a unique global minimum.</a:t>
+              <a:t>• Ridge regression offline; anchored sliding-window ridge online — always a unique global minimum.</a:t>
             </a:r>
           </a:p>
         </p:txBody>
@@ -4912,7 +4912,7 @@
                             <a:srgbClr val="FFFFFF"/>
                           </a:solidFill>
                         </a:rPr>
-                        <a:t>Ghost-Lattice RMSE</a:t>
+                        <a:t>Ghost-Lattice RMSE (batch / online)</a:t>
                       </a:r>
                     </a:p>
                   </a:txBody>
@@ -5011,7 +5011,7 @@
                             <a:srgbClr val="212121"/>
                           </a:solidFill>
                         </a:rPr>
-                        <a:t>0.012</a:t>
+                        <a:t>0.0199 / 0.0202</a:t>
                       </a:r>
                     </a:p>
                   </a:txBody>
@@ -5028,7 +5028,7 @@
                             <a:srgbClr val="212121"/>
                           </a:solidFill>
                         </a:rPr>
-                        <a:t>ESN 0.20 · GRU 0.80</a:t>
+                        <a:t>Lin 0.8779 · GRU 0.7999 · ESN 0.1751</a:t>
                       </a:r>
                     </a:p>
                   </a:txBody>
@@ -5045,7 +5045,94 @@
                             <a:srgbClr val="212121"/>
                           </a:solidFill>
                         </a:rPr>
-                        <a:t>16× – 66×</a:t>
+                        <a:t>8.8× / 8.7×</a:t>
+                      </a:r>
+                    </a:p>
+                  </a:txBody>
+                  <a:tcPr/>
+                </a:tc>
+              </a:tr>
+              <a:tr h="487680">
+                <a:tc>
+                  <a:txBody>
+                    <a:bodyPr/>
+                    <a:lstStyle/>
+                    <a:p>
+                      <a:r>
+                        <a:rPr sz="1500" b="0">
+                          <a:solidFill>
+                            <a:srgbClr val="212121"/>
+                          </a:solidFill>
+                        </a:rPr>
+                        <a:t>Mackey-Glass τ=17</a:t>
+                      </a:r>
+                    </a:p>
+                  </a:txBody>
+                  <a:tcPr/>
+                </a:tc>
+                <a:tc>
+                  <a:txBody>
+                    <a:bodyPr/>
+                    <a:lstStyle/>
+                    <a:p>
+                      <a:r>
+                        <a:rPr sz="1500" b="0">
+                          <a:solidFill>
+                            <a:srgbClr val="212121"/>
+                          </a:solidFill>
+                        </a:rPr>
+                        <a:t>12 steps</a:t>
+                      </a:r>
+                    </a:p>
+                  </a:txBody>
+                  <a:tcPr/>
+                </a:tc>
+                <a:tc>
+                  <a:txBody>
+                    <a:bodyPr/>
+                    <a:lstStyle/>
+                    <a:p>
+                      <a:r>
+                        <a:rPr sz="1500" b="0">
+                          <a:solidFill>
+                            <a:srgbClr val="212121"/>
+                          </a:solidFill>
+                        </a:rPr>
+                        <a:t>0.0188 / 0.0191</a:t>
+                      </a:r>
+                    </a:p>
+                  </a:txBody>
+                  <a:tcPr/>
+                </a:tc>
+                <a:tc>
+                  <a:txBody>
+                    <a:bodyPr/>
+                    <a:lstStyle/>
+                    <a:p>
+                      <a:r>
+                        <a:rPr sz="1500" b="0">
+                          <a:solidFill>
+                            <a:srgbClr val="212121"/>
+                          </a:solidFill>
+                        </a:rPr>
+                        <a:t>Lin 0.8053 · GRU 0.8793 · ESN 0.2705</a:t>
+                      </a:r>
+                    </a:p>
+                  </a:txBody>
+                  <a:tcPr/>
+                </a:tc>
+                <a:tc>
+                  <a:txBody>
+                    <a:bodyPr/>
+                    <a:lstStyle/>
+                    <a:p>
+                      <a:r>
+                        <a:rPr sz="1500" b="0">
+                          <a:solidFill>
+                            <a:srgbClr val="212121"/>
+                          </a:solidFill>
+                        </a:rPr>
+                        <a:t>14.4× / 14.2×</a:t>
                       </a:r>
                     </a:p>
                   </a:txBody>
@@ -5081,7 +5168,7 @@
                             <a:srgbClr val="212121"/>
                           </a:solidFill>
                         </a:rPr>
-                        <a:t>24 steps</a:t>
+                        <a:t>6 steps</a:t>
                       </a:r>
                     </a:p>
                   </a:txBody>
@@ -5098,7 +5185,7 @@
                             <a:srgbClr val="212121"/>
                           </a:solidFill>
                         </a:rPr>
-                        <a:t>0.11</a:t>
+                        <a:t>0.00127 / 0.00119</a:t>
                       </a:r>
                     </a:p>
                   </a:txBody>
@@ -5115,7 +5202,7 @@
                             <a:srgbClr val="212121"/>
                           </a:solidFill>
                         </a:rPr>
-                        <a:t>ESN 0.19 · Linear 0.54</a:t>
+                        <a:t>Lin 0.0021 · GRU 0.2571 · ESN 0.0300</a:t>
                       </a:r>
                     </a:p>
                   </a:txBody>
@@ -5132,7 +5219,7 @@
                             <a:srgbClr val="212121"/>
                           </a:solidFill>
                         </a:rPr>
-                        <a:t>1.7× – 4.9×</a:t>
+                        <a:t>23.6× / 25.2×</a:t>
                       </a:r>
                     </a:p>
                   </a:txBody>

</xml_diff>